<commit_message>
docs+deck: document enforced guarantees, adversarial-audit hardening and resolution; collapse long survivor list
</commit_message>
<xml_diff>
--- a/deck/Mutant-HackDevengers2.pptx
+++ b/deck/Mutant-HackDevengers2.pptx
@@ -15,6 +15,7 @@
     <p:sldId id="263" r:id="rId15"/>
     <p:sldId id="264" r:id="rId16"/>
     <p:sldId id="265" r:id="rId17"/>
+    <p:sldId id="266" r:id="rId18"/>
   </p:sldIdLst>
   <p:sldSz cx="12191695" cy="6858000" type="screen4x3"/>
   <p:notesSz cx="6858000" cy="9144000"/>
@@ -537,6 +538,76 @@
 </file>
 
 <file path=ppt/notesSlides/notesSlide10.xml><?xml version="1.0" encoding="utf-8"?>
+<p:notes xmlns:a="http://schemas.openxmlformats.org/drawingml/2006/main" xmlns:p="http://schemas.openxmlformats.org/presentationml/2006/main" xmlns:r="http://schemas.openxmlformats.org/officeDocument/2006/relationships">
+  <p:cSld>
+    <p:spTree>
+      <p:nvGrpSpPr>
+        <p:cNvPr id="1" name=""/>
+        <p:cNvGrpSpPr/>
+        <p:nvPr/>
+      </p:nvGrpSpPr>
+      <p:grpSpPr>
+        <a:xfrm>
+          <a:off x="0" y="0"/>
+          <a:ext cx="0" cy="0"/>
+          <a:chOff x="0" y="0"/>
+          <a:chExt cx="0" cy="0"/>
+        </a:xfrm>
+      </p:grpSpPr>
+      <p:sp>
+        <p:nvSpPr>
+          <p:cNvPr id="2" name="Slide Image Placeholder 1"/>
+          <p:cNvSpPr>
+            <a:spLocks noGrp="1"/>
+          </p:cNvSpPr>
+          <p:nvPr>
+            <p:ph type="sldImg" idx="2"/>
+          </p:nvPr>
+        </p:nvSpPr>
+        <p:spPr/>
+      </p:sp>
+      <p:sp>
+        <p:nvSpPr>
+          <p:cNvPr id="3" name="Notes Placeholder 2"/>
+          <p:cNvSpPr>
+            <a:spLocks noGrp="1"/>
+          </p:cNvSpPr>
+          <p:nvPr>
+            <p:ph type="body" idx="3" sz="quarter"/>
+          </p:nvPr>
+        </p:nvSpPr>
+        <p:spPr/>
+        <p:txBody>
+          <a:bodyPr/>
+          <a:lstStyle/>
+          <a:p>
+            <a:r>
+              <a:t>This slide exists because the fixes are the strongest evidence of engineering discipline in the project. 40s.</a:t>
+            </a:r>
+          </a:p>
+        </p:txBody>
+      </p:sp>
+      <p:sp>
+        <p:nvSpPr>
+          <p:cNvPr id="4" name="Slide Number Placeholder 3"/>
+          <p:cNvSpPr>
+            <a:spLocks noGrp="1"/>
+          </p:cNvSpPr>
+          <p:nvPr>
+            <p:ph type="sldNum" idx="5" sz="quarter"/>
+          </p:nvPr>
+        </p:nvSpPr>
+        <p:spPr/>
+      </p:sp>
+    </p:spTree>
+  </p:cSld>
+  <p:clrMapOvr>
+    <a:masterClrMapping/>
+  </p:clrMapOvr>
+</p:notes>
+</file>
+
+<file path=ppt/notesSlides/notesSlide11.xml><?xml version="1.0" encoding="utf-8"?>
 <p:notes xmlns:a="http://schemas.openxmlformats.org/drawingml/2006/main" xmlns:p="http://schemas.openxmlformats.org/presentationml/2006/main" xmlns:r="http://schemas.openxmlformats.org/officeDocument/2006/relationships">
   <p:cSld>
     <p:spTree>
@@ -4275,6 +4346,140 @@
                   <a:srgbClr val="E8ECF6"/>
                 </a:solidFill>
               </a:rPr>
+              <a:t>Hardened by an adversarial audit</a:t>
+            </a:r>
+          </a:p>
+        </p:txBody>
+      </p:sp>
+      <p:sp>
+        <p:nvSpPr>
+          <p:cNvPr id="3" name="Content Placeholder 2"/>
+          <p:cNvSpPr>
+            <a:spLocks noGrp="1"/>
+          </p:cNvSpPr>
+          <p:nvPr>
+            <p:ph idx="1"/>
+          </p:nvPr>
+        </p:nvSpPr>
+        <p:spPr/>
+        <p:txBody>
+          <a:bodyPr/>
+          <a:lstStyle/>
+          <a:p>
+            <a:pPr/>
+            <a:r>
+              <a:rPr sz="1350">
+                <a:solidFill>
+                  <a:srgbClr val="E8ECF6"/>
+                </a:solidFill>
+              </a:rPr>
+              <a:t>Before submission, the engine, runner, serverless function and every documented claim were handed to a different model for an independent adversarial read.</a:t>
+            </a:r>
+          </a:p>
+          <a:p>
+            <a:pPr/>
+            <a:r>
+              <a:rPr sz="1350">
+                <a:solidFill>
+                  <a:srgbClr val="E8ECF6"/>
+                </a:solidFill>
+              </a:rPr>
+              <a:t>It found three real defects: invalid mutants could inflate the score; the validation gate was reported but not enforced; an unparseable mutant was counted as a kill.</a:t>
+            </a:r>
+          </a:p>
+          <a:p>
+            <a:pPr/>
+            <a:r>
+              <a:rPr sz="1350">
+                <a:solidFill>
+                  <a:srgbClr val="E8ECF6"/>
+                </a:solidFill>
+              </a:rPr>
+              <a:t>All three are fixed and pinned by regression tests. Test count went 62 -&gt; 77.</a:t>
+            </a:r>
+          </a:p>
+          <a:p>
+            <a:pPr/>
+            <a:r>
+              <a:rPr sz="1350">
+                <a:solidFill>
+                  <a:srgbClr val="E8ECF6"/>
+                </a:solidFill>
+              </a:rPr>
+              <a:t>Also fixed: a client-spoofable rate-limit header (now platform IP + global ceiling), and per-mutant timings hardcoded to 0 in the export.</a:t>
+            </a:r>
+          </a:p>
+          <a:p>
+            <a:pPr/>
+            <a:r>
+              <a:rPr b="1" sz="1350">
+                <a:solidFill>
+                  <a:srgbClr val="E8ECF6"/>
+                </a:solidFill>
+              </a:rPr>
+              <a:t>The audit's own first-60-seconds attack — “show me a negative number” — is now a regression test.</a:t>
+            </a:r>
+          </a:p>
+          <a:p>
+            <a:pPr/>
+            <a:r>
+              <a:rPr sz="1350">
+                <a:solidFill>
+                  <a:srgbClr val="E8ECF6"/>
+                </a:solidFill>
+              </a:rPr>
+              <a:t>A correctness bug inside a correctness tool invalidates every other criterion, so this pass was worth more than any feature we could have added.</a:t>
+            </a:r>
+          </a:p>
+        </p:txBody>
+      </p:sp>
+    </p:spTree>
+  </p:cSld>
+  <p:clrMapOvr>
+    <a:masterClrMapping/>
+  </p:clrMapOvr>
+</p:sld>
+</file>
+
+<file path=ppt/slides/slide11.xml><?xml version="1.0" encoding="utf-8"?>
+<p:sld xmlns:a="http://schemas.openxmlformats.org/drawingml/2006/main" xmlns:p="http://schemas.openxmlformats.org/presentationml/2006/main" xmlns:r="http://schemas.openxmlformats.org/officeDocument/2006/relationships">
+  <p:cSld>
+    <p:bg>
+      <p:bgPr>
+        <a:solidFill>
+          <a:srgbClr val="07080C"/>
+        </a:solidFill>
+        <a:effectLst/>
+      </p:bgPr>
+    </p:bg>
+    <p:spTree>
+      <p:nvGrpSpPr>
+        <p:cNvPr id="1" name=""/>
+        <p:cNvGrpSpPr/>
+        <p:nvPr/>
+      </p:nvGrpSpPr>
+      <p:grpSpPr/>
+      <p:sp>
+        <p:nvSpPr>
+          <p:cNvPr id="2" name="Title 1"/>
+          <p:cNvSpPr>
+            <a:spLocks noGrp="1"/>
+          </p:cNvSpPr>
+          <p:nvPr>
+            <p:ph type="title"/>
+          </p:nvPr>
+        </p:nvSpPr>
+        <p:spPr/>
+        <p:txBody>
+          <a:bodyPr/>
+          <a:lstStyle/>
+          <a:p>
+            <a:r>
+              <a:rPr sz="2800" b="1">
+                <a:solidFill>
+                  <a:srgbClr val="E8ECF6"/>
+                </a:solidFill>
+              </a:rPr>
               <a:t>Try it in 60 seconds</a:t>
             </a:r>
           </a:p>
@@ -4831,7 +5036,7 @@
                 <a:gridCol w="2743200"/>
                 <a:gridCol w="2743200"/>
               </a:tblGrid>
-              <a:tr h="304800">
+              <a:tr h="261257">
                 <a:tc>
                   <a:txBody>
                     <a:bodyPr/>
@@ -4875,7 +5080,7 @@
                   </a:tcPr>
                 </a:tc>
               </a:tr>
-              <a:tr h="304800">
+              <a:tr h="261257">
                 <a:tc>
                   <a:txBody>
                     <a:bodyPr/>
@@ -4919,7 +5124,7 @@
                   </a:tcPr>
                 </a:tc>
               </a:tr>
-              <a:tr h="304800">
+              <a:tr h="261257">
                 <a:tc>
                   <a:txBody>
                     <a:bodyPr/>
@@ -4952,7 +5157,7 @@
                             <a:srgbClr val="E8ECF6"/>
                           </a:solidFill>
                         </a:rPr>
-                        <a:t>same example after generation: 35% -&gt; 100%, 17/17 killed</a:t>
+                        <a:t>model-written boundary tests: 35% -&gt; 100%, 17/17 killed</a:t>
                       </a:r>
                     </a:p>
                   </a:txBody>
@@ -4963,7 +5168,51 @@
                   </a:tcPr>
                 </a:tc>
               </a:tr>
-              <a:tr h="304800">
+              <a:tr h="261257">
+                <a:tc>
+                  <a:txBody>
+                    <a:bodyPr/>
+                    <a:lstStyle/>
+                    <a:p>
+                      <a:r>
+                        <a:rPr sz="1100" b="0">
+                          <a:solidFill>
+                            <a:srgbClr val="E8ECF6"/>
+                          </a:solidFill>
+                        </a:rPr>
+                        <a:t>Broken tests are excluded, not scored</a:t>
+                      </a:r>
+                    </a:p>
+                  </a:txBody>
+                  <a:tcPr>
+                    <a:solidFill>
+                      <a:srgbClr val="131722"/>
+                    </a:solidFill>
+                  </a:tcPr>
+                </a:tc>
+                <a:tc>
+                  <a:txBody>
+                    <a:bodyPr/>
+                    <a:lstStyle/>
+                    <a:p>
+                      <a:r>
+                        <a:rPr sz="1100" b="0">
+                          <a:solidFill>
+                            <a:srgbClr val="E8ECF6"/>
+                          </a:solidFill>
+                        </a:rPr>
+                        <a:t>a failing test is removed from scoring and counted: 1 excluded / 1 kept</a:t>
+                      </a:r>
+                    </a:p>
+                  </a:txBody>
+                  <a:tcPr>
+                    <a:solidFill>
+                      <a:srgbClr val="131722"/>
+                    </a:solidFill>
+                  </a:tcPr>
+                </a:tc>
+              </a:tr>
+              <a:tr h="261257">
                 <a:tc>
                   <a:txBody>
                     <a:bodyPr/>
@@ -5007,7 +5256,7 @@
                   </a:tcPr>
                 </a:tc>
               </a:tr>
-              <a:tr h="304800">
+              <a:tr h="261257">
                 <a:tc>
                   <a:txBody>
                     <a:bodyPr/>
@@ -5051,7 +5300,7 @@
                   </a:tcPr>
                 </a:tc>
               </a:tr>
-              <a:tr h="304800">
+              <a:tr h="261258">
                 <a:tc>
                   <a:txBody>
                     <a:bodyPr/>
@@ -5063,7 +5312,7 @@
                             <a:srgbClr val="E8ECF6"/>
                           </a:solidFill>
                         </a:rPr>
-                        <a:t>Engine output is valid JavaScript</a:t>
+                        <a:t>Engine output is always valid JavaScript</a:t>
                       </a:r>
                     </a:p>
                   </a:txBody>
@@ -5084,7 +5333,7 @@
                             <a:srgbClr val="E8ECF6"/>
                           </a:solidFill>
                         </a:rPr>
-                        <a:t>62/62 tests pass, every mutant re-parsed</a:t>
+                        <a:t>engine re-parses, repairs or discards every mutant; 77/77 tests</a:t>
                       </a:r>
                     </a:p>
                   </a:txBody>
@@ -5318,7 +5567,7 @@
                   <a:srgbClr val="E8ECF6"/>
                 </a:solidFill>
               </a:rPr>
-              <a:t>A test that fails before any mutation proves nothing about mutants — it is excluded and reported, never counted as a kill.</a:t>
+              <a:t>ENFORCED: every mutant is re-parsed before use. An operator flip that would produce invalid JavaScript is repaired or discarded.</a:t>
             </a:r>
           </a:p>
           <a:p>
@@ -5329,18 +5578,40 @@
                   <a:srgbClr val="E8ECF6"/>
                 </a:solidFill>
               </a:rPr>
-              <a:t>Survivors that also survive a curated boundary suite are labelled possibly equivalent.</a:t>
+              <a:t>Why that matters: an unparseable mutant is scored as a KILL — the sandbox parse throws, every test 'fails'. Left alone it inflates the score.</a:t>
             </a:r>
           </a:p>
           <a:p>
             <a:pPr/>
             <a:r>
+              <a:rPr sz="1350">
+                <a:solidFill>
+                  <a:srgbClr val="E8ECF6"/>
+                </a:solidFill>
+              </a:rPr>
+              <a:t>ENFORCED: tests failing on the ORIGINAL code are removed from the scoring run, not merely flagged. The UI reports excluded vs kept.</a:t>
+            </a:r>
+          </a:p>
+          <a:p>
+            <a:pPr/>
+            <a:r>
+              <a:rPr sz="1350">
+                <a:solidFill>
+                  <a:srgbClr val="E8ECF6"/>
+                </a:solidFill>
+              </a:rPr>
+              <a:t>If no test passes on the original, the app refuses to publish a score at all instead of showing a meaningless 0%.</a:t>
+            </a:r>
+          </a:p>
+          <a:p>
+            <a:pPr/>
+            <a:r>
               <a:rPr b="1" sz="1350">
                 <a:solidFill>
                   <a:srgbClr val="E8ECF6"/>
                 </a:solidFill>
               </a:rPr>
-              <a:t>100% mutation score is not always reachable. Pretending otherwise would be dishonest scoring.</a:t>
+              <a:t>100% mutation score is not always reachable — unkillable mutants are labelled possibly equivalent instead of hidden.</a:t>
             </a:r>
           </a:p>
           <a:p>
@@ -5351,18 +5622,7 @@
                   <a:srgbClr val="E8ECF6"/>
                 </a:solidFill>
               </a:rPr>
-              <a:t>The equivalent-mutant problem is the famous hard part of mutation testing — naming it beats hiding it.</a:t>
-            </a:r>
-          </a:p>
-          <a:p>
-            <a:pPr/>
-            <a:r>
-              <a:rPr sz="1350">
-                <a:solidFill>
-                  <a:srgbClr val="E8ECF6"/>
-                </a:solidFill>
-              </a:rPr>
-              <a:t>The full run exports as JSON: every mutant, operator, span, status and killer test, auditable offline.</a:t>
+              <a:t>The full run exports as JSON: every mutant, operator, span, status, killer test, timing and repair count.</a:t>
             </a:r>
           </a:p>
         </p:txBody>

</xml_diff>

<commit_message>
docs+deck: TypeScript support, share/kill/badge/CI features, loop slide
</commit_message>
<xml_diff>
--- a/deck/Mutant-HackDevengers2.pptx
+++ b/deck/Mutant-HackDevengers2.pptx
@@ -16,6 +16,7 @@
     <p:sldId id="264" r:id="rId16"/>
     <p:sldId id="265" r:id="rId17"/>
     <p:sldId id="266" r:id="rId18"/>
+    <p:sldId id="267" r:id="rId19"/>
   </p:sldIdLst>
   <p:sldSz cx="12191695" cy="6858000" type="screen4x3"/>
   <p:notesSz cx="6858000" cy="9144000"/>
@@ -608,6 +609,76 @@
 </file>
 
 <file path=ppt/notesSlides/notesSlide11.xml><?xml version="1.0" encoding="utf-8"?>
+<p:notes xmlns:a="http://schemas.openxmlformats.org/drawingml/2006/main" xmlns:p="http://schemas.openxmlformats.org/presentationml/2006/main" xmlns:r="http://schemas.openxmlformats.org/officeDocument/2006/relationships">
+  <p:cSld>
+    <p:spTree>
+      <p:nvGrpSpPr>
+        <p:cNvPr id="1" name=""/>
+        <p:cNvGrpSpPr/>
+        <p:nvPr/>
+      </p:nvGrpSpPr>
+      <p:grpSpPr>
+        <a:xfrm>
+          <a:off x="0" y="0"/>
+          <a:ext cx="0" cy="0"/>
+          <a:chOff x="0" y="0"/>
+          <a:chExt cx="0" cy="0"/>
+        </a:xfrm>
+      </p:grpSpPr>
+      <p:sp>
+        <p:nvSpPr>
+          <p:cNvPr id="2" name="Slide Image Placeholder 1"/>
+          <p:cNvSpPr>
+            <a:spLocks noGrp="1"/>
+          </p:cNvSpPr>
+          <p:nvPr>
+            <p:ph type="sldImg" idx="2"/>
+          </p:nvPr>
+        </p:nvSpPr>
+        <p:spPr/>
+      </p:sp>
+      <p:sp>
+        <p:nvSpPr>
+          <p:cNvPr id="3" name="Notes Placeholder 2"/>
+          <p:cNvSpPr>
+            <a:spLocks noGrp="1"/>
+          </p:cNvSpPr>
+          <p:nvPr>
+            <p:ph type="body" idx="3" sz="quarter"/>
+          </p:nvPr>
+        </p:nvSpPr>
+        <p:spPr/>
+        <p:txBody>
+          <a:bodyPr/>
+          <a:lstStyle/>
+          <a:p>
+            <a:r>
+              <a:t>The differentiators beyond correctness: a demo you can watch, and an entry that carries itself into other rooms. 45s.</a:t>
+            </a:r>
+          </a:p>
+        </p:txBody>
+      </p:sp>
+      <p:sp>
+        <p:nvSpPr>
+          <p:cNvPr id="4" name="Slide Number Placeholder 3"/>
+          <p:cNvSpPr>
+            <a:spLocks noGrp="1"/>
+          </p:cNvSpPr>
+          <p:nvPr>
+            <p:ph type="sldNum" idx="5" sz="quarter"/>
+          </p:nvPr>
+        </p:nvSpPr>
+        <p:spPr/>
+      </p:sp>
+    </p:spTree>
+  </p:cSld>
+  <p:clrMapOvr>
+    <a:masterClrMapping/>
+  </p:clrMapOvr>
+</p:notes>
+</file>
+
+<file path=ppt/notesSlides/notesSlide12.xml><?xml version="1.0" encoding="utf-8"?>
 <p:notes xmlns:a="http://schemas.openxmlformats.org/drawingml/2006/main" xmlns:p="http://schemas.openxmlformats.org/presentationml/2006/main" xmlns:r="http://schemas.openxmlformats.org/officeDocument/2006/relationships">
   <p:cSld>
     <p:spTree>
@@ -4480,6 +4551,118 @@
                   <a:srgbClr val="E8ECF6"/>
                 </a:solidFill>
               </a:rPr>
+              <a:t>A loop you can watch, and an artifact that spreads</a:t>
+            </a:r>
+          </a:p>
+        </p:txBody>
+      </p:sp>
+      <p:sp>
+        <p:nvSpPr>
+          <p:cNvPr id="3" name="Content Placeholder 2"/>
+          <p:cNvSpPr>
+            <a:spLocks noGrp="1"/>
+          </p:cNvSpPr>
+          <p:nvPr>
+            <p:ph idx="1"/>
+          </p:nvPr>
+        </p:nvSpPr>
+        <p:spPr/>
+        <p:txBody>
+          <a:bodyPr/>
+          <a:lstStyle/>
+          <a:p>
+            <a:pPr/>
+            <a:r>
+              <a:rPr sz="1350">
+                <a:solidFill>
+                  <a:srgbClr val="E8ECF6"/>
+                </a:solidFill>
+              </a:rPr>
+              <a:t>The score climbs while you watch — 35% rising to 100% — and each mutant's verdict lights up in sequence. Reduced-motion users get the same numbers without the motion.</a:t>
+            </a:r>
+          </a:p>
+          <a:p>
+            <a:pPr/>
+            <a:r>
+              <a:rPr sz="1350">
+                <a:solidFill>
+                  <a:srgbClr val="E8ECF6"/>
+                </a:solidFill>
+              </a:rPr>
+              <a:t>'Kill this mutant' targets one survivor: the model writes a test, it is verified against the original AND the mutant, then the score rises by exactly what it catches.</a:t>
+            </a:r>
+          </a:p>
+          <a:p>
+            <a:pPr/>
+            <a:r>
+              <a:rPr b="1" sz="1350">
+                <a:solidFill>
+                  <a:srgbClr val="E8ECF6"/>
+                </a:solidFill>
+              </a:rPr>
+              <a:t>Share a run as a link — the state lives in the URL, recomputes live on open, and needs no server. A judge can send a colleague the exact 35%-to-100% run.</a:t>
+            </a:r>
+          </a:p>
+          <a:p>
+            <a:pPr/>
+            <a:r>
+              <a:rPr sz="1350">
+                <a:solidFill>
+                  <a:srgbClr val="E8ECF6"/>
+                </a:solidFill>
+              </a:rPr>
+              <a:t>The README badge shows a mutation score generated from a real run, and the CI export turns the tool into a pipeline gate with a fail_below contract.</a:t>
+            </a:r>
+          </a:p>
+        </p:txBody>
+      </p:sp>
+    </p:spTree>
+  </p:cSld>
+  <p:clrMapOvr>
+    <a:masterClrMapping/>
+  </p:clrMapOvr>
+</p:sld>
+</file>
+
+<file path=ppt/slides/slide12.xml><?xml version="1.0" encoding="utf-8"?>
+<p:sld xmlns:a="http://schemas.openxmlformats.org/drawingml/2006/main" xmlns:p="http://schemas.openxmlformats.org/presentationml/2006/main" xmlns:r="http://schemas.openxmlformats.org/officeDocument/2006/relationships">
+  <p:cSld>
+    <p:bg>
+      <p:bgPr>
+        <a:solidFill>
+          <a:srgbClr val="07080C"/>
+        </a:solidFill>
+        <a:effectLst/>
+      </p:bgPr>
+    </p:bg>
+    <p:spTree>
+      <p:nvGrpSpPr>
+        <p:cNvPr id="1" name=""/>
+        <p:cNvGrpSpPr/>
+        <p:nvPr/>
+      </p:nvGrpSpPr>
+      <p:grpSpPr/>
+      <p:sp>
+        <p:nvSpPr>
+          <p:cNvPr id="2" name="Title 1"/>
+          <p:cNvSpPr>
+            <a:spLocks noGrp="1"/>
+          </p:cNvSpPr>
+          <p:nvPr>
+            <p:ph type="title"/>
+          </p:nvPr>
+        </p:nvSpPr>
+        <p:spPr/>
+        <p:txBody>
+          <a:bodyPr/>
+          <a:lstStyle/>
+          <a:p>
+            <a:r>
+              <a:rPr sz="2800" b="1">
+                <a:solidFill>
+                  <a:srgbClr val="E8ECF6"/>
+                </a:solidFill>
+              </a:rPr>
               <a:t>Try it in 60 seconds</a:t>
             </a:r>
           </a:p>
@@ -4820,6 +5003,17 @@
                 </a:solidFill>
               </a:rPr>
               <a:t>Refuses to score broken tests, and labels mutants that no input can distinguish.</a:t>
+            </a:r>
+          </a:p>
+          <a:p>
+            <a:pPr/>
+            <a:r>
+              <a:rPr sz="1350">
+                <a:solidFill>
+                  <a:srgbClr val="E8ECF6"/>
+                </a:solidFill>
+              </a:rPr>
+              <a:t>Paste JavaScript or TypeScript — types are parsed and stripped before the sandbox runs the code.</a:t>
             </a:r>
           </a:p>
         </p:txBody>
@@ -5422,7 +5616,7 @@
                   <a:srgbClr val="E8ECF6"/>
                 </a:solidFill>
               </a:rPr>
-              <a:t>1 · parse — acorn turns the function into an AST.</a:t>
+              <a:t>1 · parse — acorn + acorn-typescript turn the function (JS or TS) into an AST.</a:t>
             </a:r>
           </a:p>
           <a:p>

</xml_diff>

<commit_message>
docs+deck: reframe around 'who checks AI-written tests?', surface the verified Kill-this-mutant loop, update demo steps and test counts (110)
</commit_message>
<xml_diff>
--- a/deck/Mutant-HackDevengers2.pptx
+++ b/deck/Mutant-HackDevengers2.pptx
@@ -4344,7 +4344,7 @@
                   <a:srgbClr val="8C95AD"/>
                 </a:solidFill>
               </a:rPr>
-              <a:t>Your suite reports green. It never reports whether it would go red if the code were wrong.</a:t>
+              <a:t>AI writes more and more of our tests. Who checks them? Mutant proves whether your tests would catch a real bug.</a:t>
             </a:r>
           </a:p>
           <a:p/>
@@ -4466,7 +4466,7 @@
                   <a:srgbClr val="E8ECF6"/>
                 </a:solidFill>
               </a:rPr>
-              <a:t>All three are fixed and pinned by regression tests. Test count went 62 -&gt; 77.</a:t>
+              <a:t>All three are fixed and pinned by regression tests. A final pre-submission pass fixed five more; tests went 62 -&gt; 110.</a:t>
             </a:r>
           </a:p>
           <a:p>
@@ -4712,7 +4712,7 @@
                   <a:srgbClr val="E8ECF6"/>
                 </a:solidFill>
               </a:rPr>
-              <a:t>Verify locally: pnpm test (62 tests)  ·  pnpm verify:serve (deploy smoke test)</a:t>
+              <a:t>Verify locally: pnpm test (110 tests)  ·  pnpm verify:serve (deploy smoke test)</a:t>
             </a:r>
           </a:p>
           <a:p>
@@ -4723,7 +4723,7 @@
                   <a:srgbClr val="E8ECF6"/>
                 </a:solidFill>
               </a:rPr>
-              <a:t>The 60-second demo: load the GST example -&gt; Run mutation analysis (35%) -&gt; Generate stronger tests (re-scores automatically to 100%).</a:t>
+              <a:t>The 60-second demo: open the link — the GST example is already scored (35%, 11 of 17 bugs survive) -&gt; 'Let AI write tests that catch them' -&gt; 100%, proven.</a:t>
             </a:r>
           </a:p>
           <a:p>
@@ -4786,7 +4786,7 @@
                   <a:srgbClr val="E8ECF6"/>
                 </a:solidFill>
               </a:rPr>
-              <a:t>A green suite is not evidence</a:t>
+              <a:t>Who checks the tests?</a:t>
             </a:r>
           </a:p>
         </p:txBody>
@@ -4813,7 +4813,7 @@
                   <a:srgbClr val="E8ECF6"/>
                 </a:solidFill>
               </a:rPr>
-              <a:t>Coverage counts lines executed. It does not count bugs caught.</a:t>
+              <a:t>AI now writes a large share of our tests — and a test that can never fail looks exactly like one that works.</a:t>
             </a:r>
           </a:p>
           <a:p>
@@ -4824,7 +4824,7 @@
                   <a:srgbClr val="E8ECF6"/>
                 </a:solidFill>
               </a:rPr>
-              <a:t>A suite can hit 100% coverage and still miss every off-by-one, every flipped operator, every dropped guard.</a:t>
+              <a:t>Coverage can't tell them apart: it counts lines executed, not bugs caught. Every off-by-one and flipped operator slips through.</a:t>
             </a:r>
           </a:p>
           <a:p>
@@ -4991,7 +4991,7 @@
                   <a:srgbClr val="E8ECF6"/>
                 </a:solidFill>
               </a:rPr>
-              <a:t>Generates stronger boundary tests, re-runs, and proves the improvement as a number that moves.</a:t>
+              <a:t>Kill this mutant: an AI writes a test aimed at one survivor — kept only if it passes on the original and fails on the mutant.</a:t>
             </a:r>
           </a:p>
           <a:p>
@@ -5114,7 +5114,7 @@
                   <a:srgbClr val="E8ECF6"/>
                 </a:solidFill>
               </a:rPr>
-              <a:t>That guarantee is tested, not asserted: 62 tests, including 'every mutant re-parses' across five code shapes.</a:t>
+              <a:t>That guarantee is tested, not asserted: 110 tests, including 'every mutant re-parses' across five code shapes.</a:t>
             </a:r>
           </a:p>
           <a:p>
@@ -5527,7 +5527,7 @@
                             <a:srgbClr val="E8ECF6"/>
                           </a:solidFill>
                         </a:rPr>
-                        <a:t>engine re-parses, repairs or discards every mutant; 77/77 tests</a:t>
+                        <a:t>engine re-parses, repairs or discards every mutant; 110/110 tests</a:t>
                       </a:r>
                     </a:p>
                   </a:txBody>

</xml_diff>